<commit_message>
Italy IBR Class 2: no animations from slide 7 on
Once the class hands over to the students, a presentation slide should be
complete the moment it appears -- there is no instructor narration to pace
a build against. PLAN in _animate.py is now just the slide-3 bullet build;
the debate beats (Hdr1/Card1 -> Hdr2/Card2 -> Takeaway) and the company
beats (BriefCard -> VisitCard) are removed.

Slides 7-13 are kept OUT of SKIP rather than added to it, so a rerun still
strips any <p:timing> an earlier pass may have written; they report
"0 click-beats", which is the intended outcome.

Verified by walking MainSequence on all 16 slides: only slide 3 returns a
non-empty sequence (triggers 1,2,2,1), the other 15 are static. Slideshow-
probed 7 / 9 / 11 -- each shows its full content at entry, where slide 7
previously opened with chrome only.

Co-Authored-By: Claude Opus 5 (1M context) <noreply@anthropic.com>
</commit_message>
<xml_diff>
--- a/Italy IBR/Class 2/Class 2 - Revised.pptx
+++ b/Italy IBR/Class 2/Class 2 - Revised.pptx
@@ -5520,142 +5520,6 @@
   <p:clrMapOvr>
     <a:masterClrMapping/>
   </p:clrMapOvr>
-  <p:timing>
-    <p:tnLst>
-      <p:par>
-        <p:cTn id="1" dur="indefinite" restart="never" nodeType="tmRoot">
-          <p:childTnLst>
-            <p:seq concurrent="1" nextAc="seek">
-              <p:cTn id="2" dur="indefinite" nodeType="mainSeq">
-                <p:childTnLst>
-                  <p:par>
-                    <p:cTn id="3" fill="hold">
-                      <p:stCondLst>
-                        <p:cond delay="indefinite"/>
-                      </p:stCondLst>
-                      <p:childTnLst>
-                        <p:par>
-                          <p:cTn id="4" fill="hold">
-                            <p:stCondLst>
-                              <p:cond delay="0"/>
-                            </p:stCondLst>
-                            <p:childTnLst>
-                              <p:par>
-                                <p:cTn id="5" presetID="10" presetClass="entr" presetSubtype="0" fill="hold" grpId="0" nodeType="clickEffect">
-                                  <p:stCondLst>
-                                    <p:cond delay="0"/>
-                                  </p:stCondLst>
-                                  <p:childTnLst>
-                                    <p:set>
-                                      <p:cBhvr>
-                                        <p:cTn id="6" dur="1" fill="hold">
-                                          <p:stCondLst>
-                                            <p:cond delay="0"/>
-                                          </p:stCondLst>
-                                        </p:cTn>
-                                        <p:tgtEl>
-                                          <p:spTgt spid="256"/>
-                                        </p:tgtEl>
-                                        <p:attrNameLst>
-                                          <p:attrName>style.visibility</p:attrName>
-                                        </p:attrNameLst>
-                                      </p:cBhvr>
-                                      <p:to>
-                                        <p:strVal val="visible"/>
-                                      </p:to>
-                                    </p:set>
-                                    <p:animEffect transition="in" filter="fade">
-                                      <p:cBhvr>
-                                        <p:cTn id="7" dur="500"/>
-                                        <p:tgtEl>
-                                          <p:spTgt spid="256"/>
-                                        </p:tgtEl>
-                                      </p:cBhvr>
-                                    </p:animEffect>
-                                  </p:childTnLst>
-                                </p:cTn>
-                              </p:par>
-                            </p:childTnLst>
-                          </p:cTn>
-                        </p:par>
-                      </p:childTnLst>
-                    </p:cTn>
-                  </p:par>
-                  <p:par>
-                    <p:cTn id="8" fill="hold">
-                      <p:stCondLst>
-                        <p:cond delay="indefinite"/>
-                      </p:stCondLst>
-                      <p:childTnLst>
-                        <p:par>
-                          <p:cTn id="9" fill="hold">
-                            <p:stCondLst>
-                              <p:cond delay="0"/>
-                            </p:stCondLst>
-                            <p:childTnLst>
-                              <p:par>
-                                <p:cTn id="10" presetID="10" presetClass="entr" presetSubtype="0" fill="hold" grpId="0" nodeType="clickEffect">
-                                  <p:stCondLst>
-                                    <p:cond delay="0"/>
-                                  </p:stCondLst>
-                                  <p:childTnLst>
-                                    <p:set>
-                                      <p:cBhvr>
-                                        <p:cTn id="11" dur="1" fill="hold">
-                                          <p:stCondLst>
-                                            <p:cond delay="0"/>
-                                          </p:stCondLst>
-                                        </p:cTn>
-                                        <p:tgtEl>
-                                          <p:spTgt spid="257"/>
-                                        </p:tgtEl>
-                                        <p:attrNameLst>
-                                          <p:attrName>style.visibility</p:attrName>
-                                        </p:attrNameLst>
-                                      </p:cBhvr>
-                                      <p:to>
-                                        <p:strVal val="visible"/>
-                                      </p:to>
-                                    </p:set>
-                                    <p:animEffect transition="in" filter="fade">
-                                      <p:cBhvr>
-                                        <p:cTn id="12" dur="500"/>
-                                        <p:tgtEl>
-                                          <p:spTgt spid="257"/>
-                                        </p:tgtEl>
-                                      </p:cBhvr>
-                                    </p:animEffect>
-                                  </p:childTnLst>
-                                </p:cTn>
-                              </p:par>
-                            </p:childTnLst>
-                          </p:cTn>
-                        </p:par>
-                      </p:childTnLst>
-                    </p:cTn>
-                  </p:par>
-                </p:childTnLst>
-              </p:cTn>
-              <p:prevCondLst>
-                <p:cond evt="onPrev" delay="0">
-                  <p:tgtEl>
-                    <p:sldTgt/>
-                  </p:tgtEl>
-                </p:cond>
-              </p:prevCondLst>
-              <p:nextCondLst>
-                <p:cond evt="onNext" delay="0">
-                  <p:tgtEl>
-                    <p:sldTgt/>
-                  </p:tgtEl>
-                </p:cond>
-              </p:nextCondLst>
-            </p:seq>
-          </p:childTnLst>
-        </p:cTn>
-      </p:par>
-    </p:tnLst>
-  </p:timing>
 </p:sld>
 </file>
 
@@ -6334,142 +6198,6 @@
   <p:clrMapOvr>
     <a:masterClrMapping/>
   </p:clrMapOvr>
-  <p:timing>
-    <p:tnLst>
-      <p:par>
-        <p:cTn id="1" dur="indefinite" restart="never" nodeType="tmRoot">
-          <p:childTnLst>
-            <p:seq concurrent="1" nextAc="seek">
-              <p:cTn id="2" dur="indefinite" nodeType="mainSeq">
-                <p:childTnLst>
-                  <p:par>
-                    <p:cTn id="3" fill="hold">
-                      <p:stCondLst>
-                        <p:cond delay="indefinite"/>
-                      </p:stCondLst>
-                      <p:childTnLst>
-                        <p:par>
-                          <p:cTn id="4" fill="hold">
-                            <p:stCondLst>
-                              <p:cond delay="0"/>
-                            </p:stCondLst>
-                            <p:childTnLst>
-                              <p:par>
-                                <p:cTn id="5" presetID="10" presetClass="entr" presetSubtype="0" fill="hold" grpId="0" nodeType="clickEffect">
-                                  <p:stCondLst>
-                                    <p:cond delay="0"/>
-                                  </p:stCondLst>
-                                  <p:childTnLst>
-                                    <p:set>
-                                      <p:cBhvr>
-                                        <p:cTn id="6" dur="1" fill="hold">
-                                          <p:stCondLst>
-                                            <p:cond delay="0"/>
-                                          </p:stCondLst>
-                                        </p:cTn>
-                                        <p:tgtEl>
-                                          <p:spTgt spid="269"/>
-                                        </p:tgtEl>
-                                        <p:attrNameLst>
-                                          <p:attrName>style.visibility</p:attrName>
-                                        </p:attrNameLst>
-                                      </p:cBhvr>
-                                      <p:to>
-                                        <p:strVal val="visible"/>
-                                      </p:to>
-                                    </p:set>
-                                    <p:animEffect transition="in" filter="fade">
-                                      <p:cBhvr>
-                                        <p:cTn id="7" dur="500"/>
-                                        <p:tgtEl>
-                                          <p:spTgt spid="269"/>
-                                        </p:tgtEl>
-                                      </p:cBhvr>
-                                    </p:animEffect>
-                                  </p:childTnLst>
-                                </p:cTn>
-                              </p:par>
-                            </p:childTnLst>
-                          </p:cTn>
-                        </p:par>
-                      </p:childTnLst>
-                    </p:cTn>
-                  </p:par>
-                  <p:par>
-                    <p:cTn id="8" fill="hold">
-                      <p:stCondLst>
-                        <p:cond delay="indefinite"/>
-                      </p:stCondLst>
-                      <p:childTnLst>
-                        <p:par>
-                          <p:cTn id="9" fill="hold">
-                            <p:stCondLst>
-                              <p:cond delay="0"/>
-                            </p:stCondLst>
-                            <p:childTnLst>
-                              <p:par>
-                                <p:cTn id="10" presetID="10" presetClass="entr" presetSubtype="0" fill="hold" grpId="0" nodeType="clickEffect">
-                                  <p:stCondLst>
-                                    <p:cond delay="0"/>
-                                  </p:stCondLst>
-                                  <p:childTnLst>
-                                    <p:set>
-                                      <p:cBhvr>
-                                        <p:cTn id="11" dur="1" fill="hold">
-                                          <p:stCondLst>
-                                            <p:cond delay="0"/>
-                                          </p:stCondLst>
-                                        </p:cTn>
-                                        <p:tgtEl>
-                                          <p:spTgt spid="270"/>
-                                        </p:tgtEl>
-                                        <p:attrNameLst>
-                                          <p:attrName>style.visibility</p:attrName>
-                                        </p:attrNameLst>
-                                      </p:cBhvr>
-                                      <p:to>
-                                        <p:strVal val="visible"/>
-                                      </p:to>
-                                    </p:set>
-                                    <p:animEffect transition="in" filter="fade">
-                                      <p:cBhvr>
-                                        <p:cTn id="12" dur="500"/>
-                                        <p:tgtEl>
-                                          <p:spTgt spid="270"/>
-                                        </p:tgtEl>
-                                      </p:cBhvr>
-                                    </p:animEffect>
-                                  </p:childTnLst>
-                                </p:cTn>
-                              </p:par>
-                            </p:childTnLst>
-                          </p:cTn>
-                        </p:par>
-                      </p:childTnLst>
-                    </p:cTn>
-                  </p:par>
-                </p:childTnLst>
-              </p:cTn>
-              <p:prevCondLst>
-                <p:cond evt="onPrev" delay="0">
-                  <p:tgtEl>
-                    <p:sldTgt/>
-                  </p:tgtEl>
-                </p:cond>
-              </p:prevCondLst>
-              <p:nextCondLst>
-                <p:cond evt="onNext" delay="0">
-                  <p:tgtEl>
-                    <p:sldTgt/>
-                  </p:tgtEl>
-                </p:cond>
-              </p:nextCondLst>
-            </p:seq>
-          </p:childTnLst>
-        </p:cTn>
-      </p:par>
-    </p:tnLst>
-  </p:timing>
 </p:sld>
 </file>
 
@@ -7148,142 +6876,6 @@
   <p:clrMapOvr>
     <a:masterClrMapping/>
   </p:clrMapOvr>
-  <p:timing>
-    <p:tnLst>
-      <p:par>
-        <p:cTn id="1" dur="indefinite" restart="never" nodeType="tmRoot">
-          <p:childTnLst>
-            <p:seq concurrent="1" nextAc="seek">
-              <p:cTn id="2" dur="indefinite" nodeType="mainSeq">
-                <p:childTnLst>
-                  <p:par>
-                    <p:cTn id="3" fill="hold">
-                      <p:stCondLst>
-                        <p:cond delay="indefinite"/>
-                      </p:stCondLst>
-                      <p:childTnLst>
-                        <p:par>
-                          <p:cTn id="4" fill="hold">
-                            <p:stCondLst>
-                              <p:cond delay="0"/>
-                            </p:stCondLst>
-                            <p:childTnLst>
-                              <p:par>
-                                <p:cTn id="5" presetID="10" presetClass="entr" presetSubtype="0" fill="hold" grpId="0" nodeType="clickEffect">
-                                  <p:stCondLst>
-                                    <p:cond delay="0"/>
-                                  </p:stCondLst>
-                                  <p:childTnLst>
-                                    <p:set>
-                                      <p:cBhvr>
-                                        <p:cTn id="6" dur="1" fill="hold">
-                                          <p:stCondLst>
-                                            <p:cond delay="0"/>
-                                          </p:stCondLst>
-                                        </p:cTn>
-                                        <p:tgtEl>
-                                          <p:spTgt spid="282"/>
-                                        </p:tgtEl>
-                                        <p:attrNameLst>
-                                          <p:attrName>style.visibility</p:attrName>
-                                        </p:attrNameLst>
-                                      </p:cBhvr>
-                                      <p:to>
-                                        <p:strVal val="visible"/>
-                                      </p:to>
-                                    </p:set>
-                                    <p:animEffect transition="in" filter="fade">
-                                      <p:cBhvr>
-                                        <p:cTn id="7" dur="500"/>
-                                        <p:tgtEl>
-                                          <p:spTgt spid="282"/>
-                                        </p:tgtEl>
-                                      </p:cBhvr>
-                                    </p:animEffect>
-                                  </p:childTnLst>
-                                </p:cTn>
-                              </p:par>
-                            </p:childTnLst>
-                          </p:cTn>
-                        </p:par>
-                      </p:childTnLst>
-                    </p:cTn>
-                  </p:par>
-                  <p:par>
-                    <p:cTn id="8" fill="hold">
-                      <p:stCondLst>
-                        <p:cond delay="indefinite"/>
-                      </p:stCondLst>
-                      <p:childTnLst>
-                        <p:par>
-                          <p:cTn id="9" fill="hold">
-                            <p:stCondLst>
-                              <p:cond delay="0"/>
-                            </p:stCondLst>
-                            <p:childTnLst>
-                              <p:par>
-                                <p:cTn id="10" presetID="10" presetClass="entr" presetSubtype="0" fill="hold" grpId="0" nodeType="clickEffect">
-                                  <p:stCondLst>
-                                    <p:cond delay="0"/>
-                                  </p:stCondLst>
-                                  <p:childTnLst>
-                                    <p:set>
-                                      <p:cBhvr>
-                                        <p:cTn id="11" dur="1" fill="hold">
-                                          <p:stCondLst>
-                                            <p:cond delay="0"/>
-                                          </p:stCondLst>
-                                        </p:cTn>
-                                        <p:tgtEl>
-                                          <p:spTgt spid="283"/>
-                                        </p:tgtEl>
-                                        <p:attrNameLst>
-                                          <p:attrName>style.visibility</p:attrName>
-                                        </p:attrNameLst>
-                                      </p:cBhvr>
-                                      <p:to>
-                                        <p:strVal val="visible"/>
-                                      </p:to>
-                                    </p:set>
-                                    <p:animEffect transition="in" filter="fade">
-                                      <p:cBhvr>
-                                        <p:cTn id="12" dur="500"/>
-                                        <p:tgtEl>
-                                          <p:spTgt spid="283"/>
-                                        </p:tgtEl>
-                                      </p:cBhvr>
-                                    </p:animEffect>
-                                  </p:childTnLst>
-                                </p:cTn>
-                              </p:par>
-                            </p:childTnLst>
-                          </p:cTn>
-                        </p:par>
-                      </p:childTnLst>
-                    </p:cTn>
-                  </p:par>
-                </p:childTnLst>
-              </p:cTn>
-              <p:prevCondLst>
-                <p:cond evt="onPrev" delay="0">
-                  <p:tgtEl>
-                    <p:sldTgt/>
-                  </p:tgtEl>
-                </p:cond>
-              </p:prevCondLst>
-              <p:nextCondLst>
-                <p:cond evt="onNext" delay="0">
-                  <p:tgtEl>
-                    <p:sldTgt/>
-                  </p:tgtEl>
-                </p:cond>
-              </p:nextCondLst>
-            </p:seq>
-          </p:childTnLst>
-        </p:cTn>
-      </p:par>
-    </p:tnLst>
-  </p:timing>
 </p:sld>
 </file>
 
@@ -12573,265 +12165,6 @@
   <p:clrMapOvr>
     <a:masterClrMapping/>
   </p:clrMapOvr>
-  <p:timing>
-    <p:tnLst>
-      <p:par>
-        <p:cTn id="1" dur="indefinite" restart="never" nodeType="tmRoot">
-          <p:childTnLst>
-            <p:seq concurrent="1" nextAc="seek">
-              <p:cTn id="2" dur="indefinite" nodeType="mainSeq">
-                <p:childTnLst>
-                  <p:par>
-                    <p:cTn id="3" fill="hold">
-                      <p:stCondLst>
-                        <p:cond delay="indefinite"/>
-                      </p:stCondLst>
-                      <p:childTnLst>
-                        <p:par>
-                          <p:cTn id="4" fill="hold">
-                            <p:stCondLst>
-                              <p:cond delay="0"/>
-                            </p:stCondLst>
-                            <p:childTnLst>
-                              <p:par>
-                                <p:cTn id="5" presetID="10" presetClass="entr" presetSubtype="0" fill="hold" grpId="0" nodeType="clickEffect">
-                                  <p:stCondLst>
-                                    <p:cond delay="0"/>
-                                  </p:stCondLst>
-                                  <p:childTnLst>
-                                    <p:set>
-                                      <p:cBhvr>
-                                        <p:cTn id="6" dur="1" fill="hold">
-                                          <p:stCondLst>
-                                            <p:cond delay="0"/>
-                                          </p:stCondLst>
-                                        </p:cTn>
-                                        <p:tgtEl>
-                                          <p:spTgt spid="200"/>
-                                        </p:tgtEl>
-                                        <p:attrNameLst>
-                                          <p:attrName>style.visibility</p:attrName>
-                                        </p:attrNameLst>
-                                      </p:cBhvr>
-                                      <p:to>
-                                        <p:strVal val="visible"/>
-                                      </p:to>
-                                    </p:set>
-                                    <p:animEffect transition="in" filter="fade">
-                                      <p:cBhvr>
-                                        <p:cTn id="7" dur="500"/>
-                                        <p:tgtEl>
-                                          <p:spTgt spid="200"/>
-                                        </p:tgtEl>
-                                      </p:cBhvr>
-                                    </p:animEffect>
-                                  </p:childTnLst>
-                                </p:cTn>
-                              </p:par>
-                              <p:par>
-                                <p:cTn id="8" presetID="10" presetClass="entr" presetSubtype="0" fill="hold" grpId="0" nodeType="withEffect">
-                                  <p:stCondLst>
-                                    <p:cond delay="0"/>
-                                  </p:stCondLst>
-                                  <p:childTnLst>
-                                    <p:set>
-                                      <p:cBhvr>
-                                        <p:cTn id="9" dur="1" fill="hold">
-                                          <p:stCondLst>
-                                            <p:cond delay="0"/>
-                                          </p:stCondLst>
-                                        </p:cTn>
-                                        <p:tgtEl>
-                                          <p:spTgt spid="201"/>
-                                        </p:tgtEl>
-                                        <p:attrNameLst>
-                                          <p:attrName>style.visibility</p:attrName>
-                                        </p:attrNameLst>
-                                      </p:cBhvr>
-                                      <p:to>
-                                        <p:strVal val="visible"/>
-                                      </p:to>
-                                    </p:set>
-                                    <p:animEffect transition="in" filter="fade">
-                                      <p:cBhvr>
-                                        <p:cTn id="10" dur="500"/>
-                                        <p:tgtEl>
-                                          <p:spTgt spid="201"/>
-                                        </p:tgtEl>
-                                      </p:cBhvr>
-                                    </p:animEffect>
-                                  </p:childTnLst>
-                                </p:cTn>
-                              </p:par>
-                            </p:childTnLst>
-                          </p:cTn>
-                        </p:par>
-                      </p:childTnLst>
-                    </p:cTn>
-                  </p:par>
-                  <p:par>
-                    <p:cTn id="11" fill="hold">
-                      <p:stCondLst>
-                        <p:cond delay="indefinite"/>
-                      </p:stCondLst>
-                      <p:childTnLst>
-                        <p:par>
-                          <p:cTn id="12" fill="hold">
-                            <p:stCondLst>
-                              <p:cond delay="0"/>
-                            </p:stCondLst>
-                            <p:childTnLst>
-                              <p:par>
-                                <p:cTn id="13" presetID="10" presetClass="entr" presetSubtype="0" fill="hold" grpId="0" nodeType="clickEffect">
-                                  <p:stCondLst>
-                                    <p:cond delay="0"/>
-                                  </p:stCondLst>
-                                  <p:childTnLst>
-                                    <p:set>
-                                      <p:cBhvr>
-                                        <p:cTn id="14" dur="1" fill="hold">
-                                          <p:stCondLst>
-                                            <p:cond delay="0"/>
-                                          </p:stCondLst>
-                                        </p:cTn>
-                                        <p:tgtEl>
-                                          <p:spTgt spid="202"/>
-                                        </p:tgtEl>
-                                        <p:attrNameLst>
-                                          <p:attrName>style.visibility</p:attrName>
-                                        </p:attrNameLst>
-                                      </p:cBhvr>
-                                      <p:to>
-                                        <p:strVal val="visible"/>
-                                      </p:to>
-                                    </p:set>
-                                    <p:animEffect transition="in" filter="fade">
-                                      <p:cBhvr>
-                                        <p:cTn id="15" dur="500"/>
-                                        <p:tgtEl>
-                                          <p:spTgt spid="202"/>
-                                        </p:tgtEl>
-                                      </p:cBhvr>
-                                    </p:animEffect>
-                                  </p:childTnLst>
-                                </p:cTn>
-                              </p:par>
-                              <p:par>
-                                <p:cTn id="16" presetID="10" presetClass="entr" presetSubtype="0" fill="hold" grpId="0" nodeType="withEffect">
-                                  <p:stCondLst>
-                                    <p:cond delay="0"/>
-                                  </p:stCondLst>
-                                  <p:childTnLst>
-                                    <p:set>
-                                      <p:cBhvr>
-                                        <p:cTn id="17" dur="1" fill="hold">
-                                          <p:stCondLst>
-                                            <p:cond delay="0"/>
-                                          </p:stCondLst>
-                                        </p:cTn>
-                                        <p:tgtEl>
-                                          <p:spTgt spid="203"/>
-                                        </p:tgtEl>
-                                        <p:attrNameLst>
-                                          <p:attrName>style.visibility</p:attrName>
-                                        </p:attrNameLst>
-                                      </p:cBhvr>
-                                      <p:to>
-                                        <p:strVal val="visible"/>
-                                      </p:to>
-                                    </p:set>
-                                    <p:animEffect transition="in" filter="fade">
-                                      <p:cBhvr>
-                                        <p:cTn id="18" dur="500"/>
-                                        <p:tgtEl>
-                                          <p:spTgt spid="203"/>
-                                        </p:tgtEl>
-                                      </p:cBhvr>
-                                    </p:animEffect>
-                                  </p:childTnLst>
-                                </p:cTn>
-                              </p:par>
-                            </p:childTnLst>
-                          </p:cTn>
-                        </p:par>
-                      </p:childTnLst>
-                    </p:cTn>
-                  </p:par>
-                  <p:par>
-                    <p:cTn id="19" fill="hold">
-                      <p:stCondLst>
-                        <p:cond delay="indefinite"/>
-                      </p:stCondLst>
-                      <p:childTnLst>
-                        <p:par>
-                          <p:cTn id="20" fill="hold">
-                            <p:stCondLst>
-                              <p:cond delay="0"/>
-                            </p:stCondLst>
-                            <p:childTnLst>
-                              <p:par>
-                                <p:cTn id="21" presetID="10" presetClass="entr" presetSubtype="0" fill="hold" grpId="0" nodeType="clickEffect">
-                                  <p:stCondLst>
-                                    <p:cond delay="0"/>
-                                  </p:stCondLst>
-                                  <p:childTnLst>
-                                    <p:set>
-                                      <p:cBhvr>
-                                        <p:cTn id="22" dur="1" fill="hold">
-                                          <p:stCondLst>
-                                            <p:cond delay="0"/>
-                                          </p:stCondLst>
-                                        </p:cTn>
-                                        <p:tgtEl>
-                                          <p:spTgt spid="204"/>
-                                        </p:tgtEl>
-                                        <p:attrNameLst>
-                                          <p:attrName>style.visibility</p:attrName>
-                                        </p:attrNameLst>
-                                      </p:cBhvr>
-                                      <p:to>
-                                        <p:strVal val="visible"/>
-                                      </p:to>
-                                    </p:set>
-                                    <p:animEffect transition="in" filter="fade">
-                                      <p:cBhvr>
-                                        <p:cTn id="23" dur="500"/>
-                                        <p:tgtEl>
-                                          <p:spTgt spid="204"/>
-                                        </p:tgtEl>
-                                      </p:cBhvr>
-                                    </p:animEffect>
-                                  </p:childTnLst>
-                                </p:cTn>
-                              </p:par>
-                            </p:childTnLst>
-                          </p:cTn>
-                        </p:par>
-                      </p:childTnLst>
-                    </p:cTn>
-                  </p:par>
-                </p:childTnLst>
-              </p:cTn>
-              <p:prevCondLst>
-                <p:cond evt="onPrev" delay="0">
-                  <p:tgtEl>
-                    <p:sldTgt/>
-                  </p:tgtEl>
-                </p:cond>
-              </p:prevCondLst>
-              <p:nextCondLst>
-                <p:cond evt="onNext" delay="0">
-                  <p:tgtEl>
-                    <p:sldTgt/>
-                  </p:tgtEl>
-                </p:cond>
-              </p:nextCondLst>
-            </p:seq>
-          </p:childTnLst>
-        </p:cTn>
-      </p:par>
-    </p:tnLst>
-  </p:timing>
 </p:sld>
 </file>
 
@@ -13510,142 +12843,6 @@
   <p:clrMapOvr>
     <a:masterClrMapping/>
   </p:clrMapOvr>
-  <p:timing>
-    <p:tnLst>
-      <p:par>
-        <p:cTn id="1" dur="indefinite" restart="never" nodeType="tmRoot">
-          <p:childTnLst>
-            <p:seq concurrent="1" nextAc="seek">
-              <p:cTn id="2" dur="indefinite" nodeType="mainSeq">
-                <p:childTnLst>
-                  <p:par>
-                    <p:cTn id="3" fill="hold">
-                      <p:stCondLst>
-                        <p:cond delay="indefinite"/>
-                      </p:stCondLst>
-                      <p:childTnLst>
-                        <p:par>
-                          <p:cTn id="4" fill="hold">
-                            <p:stCondLst>
-                              <p:cond delay="0"/>
-                            </p:stCondLst>
-                            <p:childTnLst>
-                              <p:par>
-                                <p:cTn id="5" presetID="10" presetClass="entr" presetSubtype="0" fill="hold" grpId="0" nodeType="clickEffect">
-                                  <p:stCondLst>
-                                    <p:cond delay="0"/>
-                                  </p:stCondLst>
-                                  <p:childTnLst>
-                                    <p:set>
-                                      <p:cBhvr>
-                                        <p:cTn id="6" dur="1" fill="hold">
-                                          <p:stCondLst>
-                                            <p:cond delay="0"/>
-                                          </p:stCondLst>
-                                        </p:cTn>
-                                        <p:tgtEl>
-                                          <p:spTgt spid="216"/>
-                                        </p:tgtEl>
-                                        <p:attrNameLst>
-                                          <p:attrName>style.visibility</p:attrName>
-                                        </p:attrNameLst>
-                                      </p:cBhvr>
-                                      <p:to>
-                                        <p:strVal val="visible"/>
-                                      </p:to>
-                                    </p:set>
-                                    <p:animEffect transition="in" filter="fade">
-                                      <p:cBhvr>
-                                        <p:cTn id="7" dur="500"/>
-                                        <p:tgtEl>
-                                          <p:spTgt spid="216"/>
-                                        </p:tgtEl>
-                                      </p:cBhvr>
-                                    </p:animEffect>
-                                  </p:childTnLst>
-                                </p:cTn>
-                              </p:par>
-                            </p:childTnLst>
-                          </p:cTn>
-                        </p:par>
-                      </p:childTnLst>
-                    </p:cTn>
-                  </p:par>
-                  <p:par>
-                    <p:cTn id="8" fill="hold">
-                      <p:stCondLst>
-                        <p:cond delay="indefinite"/>
-                      </p:stCondLst>
-                      <p:childTnLst>
-                        <p:par>
-                          <p:cTn id="9" fill="hold">
-                            <p:stCondLst>
-                              <p:cond delay="0"/>
-                            </p:stCondLst>
-                            <p:childTnLst>
-                              <p:par>
-                                <p:cTn id="10" presetID="10" presetClass="entr" presetSubtype="0" fill="hold" grpId="0" nodeType="clickEffect">
-                                  <p:stCondLst>
-                                    <p:cond delay="0"/>
-                                  </p:stCondLst>
-                                  <p:childTnLst>
-                                    <p:set>
-                                      <p:cBhvr>
-                                        <p:cTn id="11" dur="1" fill="hold">
-                                          <p:stCondLst>
-                                            <p:cond delay="0"/>
-                                          </p:stCondLst>
-                                        </p:cTn>
-                                        <p:tgtEl>
-                                          <p:spTgt spid="217"/>
-                                        </p:tgtEl>
-                                        <p:attrNameLst>
-                                          <p:attrName>style.visibility</p:attrName>
-                                        </p:attrNameLst>
-                                      </p:cBhvr>
-                                      <p:to>
-                                        <p:strVal val="visible"/>
-                                      </p:to>
-                                    </p:set>
-                                    <p:animEffect transition="in" filter="fade">
-                                      <p:cBhvr>
-                                        <p:cTn id="12" dur="500"/>
-                                        <p:tgtEl>
-                                          <p:spTgt spid="217"/>
-                                        </p:tgtEl>
-                                      </p:cBhvr>
-                                    </p:animEffect>
-                                  </p:childTnLst>
-                                </p:cTn>
-                              </p:par>
-                            </p:childTnLst>
-                          </p:cTn>
-                        </p:par>
-                      </p:childTnLst>
-                    </p:cTn>
-                  </p:par>
-                </p:childTnLst>
-              </p:cTn>
-              <p:prevCondLst>
-                <p:cond evt="onPrev" delay="0">
-                  <p:tgtEl>
-                    <p:sldTgt/>
-                  </p:tgtEl>
-                </p:cond>
-              </p:prevCondLst>
-              <p:nextCondLst>
-                <p:cond evt="onNext" delay="0">
-                  <p:tgtEl>
-                    <p:sldTgt/>
-                  </p:tgtEl>
-                </p:cond>
-              </p:nextCondLst>
-            </p:seq>
-          </p:childTnLst>
-        </p:cTn>
-      </p:par>
-    </p:tnLst>
-  </p:timing>
 </p:sld>
 </file>
 
@@ -14282,265 +13479,6 @@
   <p:clrMapOvr>
     <a:masterClrMapping/>
   </p:clrMapOvr>
-  <p:timing>
-    <p:tnLst>
-      <p:par>
-        <p:cTn id="1" dur="indefinite" restart="never" nodeType="tmRoot">
-          <p:childTnLst>
-            <p:seq concurrent="1" nextAc="seek">
-              <p:cTn id="2" dur="indefinite" nodeType="mainSeq">
-                <p:childTnLst>
-                  <p:par>
-                    <p:cTn id="3" fill="hold">
-                      <p:stCondLst>
-                        <p:cond delay="indefinite"/>
-                      </p:stCondLst>
-                      <p:childTnLst>
-                        <p:par>
-                          <p:cTn id="4" fill="hold">
-                            <p:stCondLst>
-                              <p:cond delay="0"/>
-                            </p:stCondLst>
-                            <p:childTnLst>
-                              <p:par>
-                                <p:cTn id="5" presetID="10" presetClass="entr" presetSubtype="0" fill="hold" grpId="0" nodeType="clickEffect">
-                                  <p:stCondLst>
-                                    <p:cond delay="0"/>
-                                  </p:stCondLst>
-                                  <p:childTnLst>
-                                    <p:set>
-                                      <p:cBhvr>
-                                        <p:cTn id="6" dur="1" fill="hold">
-                                          <p:stCondLst>
-                                            <p:cond delay="0"/>
-                                          </p:stCondLst>
-                                        </p:cTn>
-                                        <p:tgtEl>
-                                          <p:spTgt spid="227"/>
-                                        </p:tgtEl>
-                                        <p:attrNameLst>
-                                          <p:attrName>style.visibility</p:attrName>
-                                        </p:attrNameLst>
-                                      </p:cBhvr>
-                                      <p:to>
-                                        <p:strVal val="visible"/>
-                                      </p:to>
-                                    </p:set>
-                                    <p:animEffect transition="in" filter="fade">
-                                      <p:cBhvr>
-                                        <p:cTn id="7" dur="500"/>
-                                        <p:tgtEl>
-                                          <p:spTgt spid="227"/>
-                                        </p:tgtEl>
-                                      </p:cBhvr>
-                                    </p:animEffect>
-                                  </p:childTnLst>
-                                </p:cTn>
-                              </p:par>
-                              <p:par>
-                                <p:cTn id="8" presetID="10" presetClass="entr" presetSubtype="0" fill="hold" grpId="0" nodeType="withEffect">
-                                  <p:stCondLst>
-                                    <p:cond delay="0"/>
-                                  </p:stCondLst>
-                                  <p:childTnLst>
-                                    <p:set>
-                                      <p:cBhvr>
-                                        <p:cTn id="9" dur="1" fill="hold">
-                                          <p:stCondLst>
-                                            <p:cond delay="0"/>
-                                          </p:stCondLst>
-                                        </p:cTn>
-                                        <p:tgtEl>
-                                          <p:spTgt spid="228"/>
-                                        </p:tgtEl>
-                                        <p:attrNameLst>
-                                          <p:attrName>style.visibility</p:attrName>
-                                        </p:attrNameLst>
-                                      </p:cBhvr>
-                                      <p:to>
-                                        <p:strVal val="visible"/>
-                                      </p:to>
-                                    </p:set>
-                                    <p:animEffect transition="in" filter="fade">
-                                      <p:cBhvr>
-                                        <p:cTn id="10" dur="500"/>
-                                        <p:tgtEl>
-                                          <p:spTgt spid="228"/>
-                                        </p:tgtEl>
-                                      </p:cBhvr>
-                                    </p:animEffect>
-                                  </p:childTnLst>
-                                </p:cTn>
-                              </p:par>
-                            </p:childTnLst>
-                          </p:cTn>
-                        </p:par>
-                      </p:childTnLst>
-                    </p:cTn>
-                  </p:par>
-                  <p:par>
-                    <p:cTn id="11" fill="hold">
-                      <p:stCondLst>
-                        <p:cond delay="indefinite"/>
-                      </p:stCondLst>
-                      <p:childTnLst>
-                        <p:par>
-                          <p:cTn id="12" fill="hold">
-                            <p:stCondLst>
-                              <p:cond delay="0"/>
-                            </p:stCondLst>
-                            <p:childTnLst>
-                              <p:par>
-                                <p:cTn id="13" presetID="10" presetClass="entr" presetSubtype="0" fill="hold" grpId="0" nodeType="clickEffect">
-                                  <p:stCondLst>
-                                    <p:cond delay="0"/>
-                                  </p:stCondLst>
-                                  <p:childTnLst>
-                                    <p:set>
-                                      <p:cBhvr>
-                                        <p:cTn id="14" dur="1" fill="hold">
-                                          <p:stCondLst>
-                                            <p:cond delay="0"/>
-                                          </p:stCondLst>
-                                        </p:cTn>
-                                        <p:tgtEl>
-                                          <p:spTgt spid="229"/>
-                                        </p:tgtEl>
-                                        <p:attrNameLst>
-                                          <p:attrName>style.visibility</p:attrName>
-                                        </p:attrNameLst>
-                                      </p:cBhvr>
-                                      <p:to>
-                                        <p:strVal val="visible"/>
-                                      </p:to>
-                                    </p:set>
-                                    <p:animEffect transition="in" filter="fade">
-                                      <p:cBhvr>
-                                        <p:cTn id="15" dur="500"/>
-                                        <p:tgtEl>
-                                          <p:spTgt spid="229"/>
-                                        </p:tgtEl>
-                                      </p:cBhvr>
-                                    </p:animEffect>
-                                  </p:childTnLst>
-                                </p:cTn>
-                              </p:par>
-                              <p:par>
-                                <p:cTn id="16" presetID="10" presetClass="entr" presetSubtype="0" fill="hold" grpId="0" nodeType="withEffect">
-                                  <p:stCondLst>
-                                    <p:cond delay="0"/>
-                                  </p:stCondLst>
-                                  <p:childTnLst>
-                                    <p:set>
-                                      <p:cBhvr>
-                                        <p:cTn id="17" dur="1" fill="hold">
-                                          <p:stCondLst>
-                                            <p:cond delay="0"/>
-                                          </p:stCondLst>
-                                        </p:cTn>
-                                        <p:tgtEl>
-                                          <p:spTgt spid="230"/>
-                                        </p:tgtEl>
-                                        <p:attrNameLst>
-                                          <p:attrName>style.visibility</p:attrName>
-                                        </p:attrNameLst>
-                                      </p:cBhvr>
-                                      <p:to>
-                                        <p:strVal val="visible"/>
-                                      </p:to>
-                                    </p:set>
-                                    <p:animEffect transition="in" filter="fade">
-                                      <p:cBhvr>
-                                        <p:cTn id="18" dur="500"/>
-                                        <p:tgtEl>
-                                          <p:spTgt spid="230"/>
-                                        </p:tgtEl>
-                                      </p:cBhvr>
-                                    </p:animEffect>
-                                  </p:childTnLst>
-                                </p:cTn>
-                              </p:par>
-                            </p:childTnLst>
-                          </p:cTn>
-                        </p:par>
-                      </p:childTnLst>
-                    </p:cTn>
-                  </p:par>
-                  <p:par>
-                    <p:cTn id="19" fill="hold">
-                      <p:stCondLst>
-                        <p:cond delay="indefinite"/>
-                      </p:stCondLst>
-                      <p:childTnLst>
-                        <p:par>
-                          <p:cTn id="20" fill="hold">
-                            <p:stCondLst>
-                              <p:cond delay="0"/>
-                            </p:stCondLst>
-                            <p:childTnLst>
-                              <p:par>
-                                <p:cTn id="21" presetID="10" presetClass="entr" presetSubtype="0" fill="hold" grpId="0" nodeType="clickEffect">
-                                  <p:stCondLst>
-                                    <p:cond delay="0"/>
-                                  </p:stCondLst>
-                                  <p:childTnLst>
-                                    <p:set>
-                                      <p:cBhvr>
-                                        <p:cTn id="22" dur="1" fill="hold">
-                                          <p:stCondLst>
-                                            <p:cond delay="0"/>
-                                          </p:stCondLst>
-                                        </p:cTn>
-                                        <p:tgtEl>
-                                          <p:spTgt spid="231"/>
-                                        </p:tgtEl>
-                                        <p:attrNameLst>
-                                          <p:attrName>style.visibility</p:attrName>
-                                        </p:attrNameLst>
-                                      </p:cBhvr>
-                                      <p:to>
-                                        <p:strVal val="visible"/>
-                                      </p:to>
-                                    </p:set>
-                                    <p:animEffect transition="in" filter="fade">
-                                      <p:cBhvr>
-                                        <p:cTn id="23" dur="500"/>
-                                        <p:tgtEl>
-                                          <p:spTgt spid="231"/>
-                                        </p:tgtEl>
-                                      </p:cBhvr>
-                                    </p:animEffect>
-                                  </p:childTnLst>
-                                </p:cTn>
-                              </p:par>
-                            </p:childTnLst>
-                          </p:cTn>
-                        </p:par>
-                      </p:childTnLst>
-                    </p:cTn>
-                  </p:par>
-                </p:childTnLst>
-              </p:cTn>
-              <p:prevCondLst>
-                <p:cond evt="onPrev" delay="0">
-                  <p:tgtEl>
-                    <p:sldTgt/>
-                  </p:tgtEl>
-                </p:cond>
-              </p:prevCondLst>
-              <p:nextCondLst>
-                <p:cond evt="onNext" delay="0">
-                  <p:tgtEl>
-                    <p:sldTgt/>
-                  </p:tgtEl>
-                </p:cond>
-              </p:nextCondLst>
-            </p:seq>
-          </p:childTnLst>
-        </p:cTn>
-      </p:par>
-    </p:tnLst>
-  </p:timing>
 </p:sld>
 </file>
 
@@ -15219,142 +14157,6 @@
   <p:clrMapOvr>
     <a:masterClrMapping/>
   </p:clrMapOvr>
-  <p:timing>
-    <p:tnLst>
-      <p:par>
-        <p:cTn id="1" dur="indefinite" restart="never" nodeType="tmRoot">
-          <p:childTnLst>
-            <p:seq concurrent="1" nextAc="seek">
-              <p:cTn id="2" dur="indefinite" nodeType="mainSeq">
-                <p:childTnLst>
-                  <p:par>
-                    <p:cTn id="3" fill="hold">
-                      <p:stCondLst>
-                        <p:cond delay="indefinite"/>
-                      </p:stCondLst>
-                      <p:childTnLst>
-                        <p:par>
-                          <p:cTn id="4" fill="hold">
-                            <p:stCondLst>
-                              <p:cond delay="0"/>
-                            </p:stCondLst>
-                            <p:childTnLst>
-                              <p:par>
-                                <p:cTn id="5" presetID="10" presetClass="entr" presetSubtype="0" fill="hold" grpId="0" nodeType="clickEffect">
-                                  <p:stCondLst>
-                                    <p:cond delay="0"/>
-                                  </p:stCondLst>
-                                  <p:childTnLst>
-                                    <p:set>
-                                      <p:cBhvr>
-                                        <p:cTn id="6" dur="1" fill="hold">
-                                          <p:stCondLst>
-                                            <p:cond delay="0"/>
-                                          </p:stCondLst>
-                                        </p:cTn>
-                                        <p:tgtEl>
-                                          <p:spTgt spid="243"/>
-                                        </p:tgtEl>
-                                        <p:attrNameLst>
-                                          <p:attrName>style.visibility</p:attrName>
-                                        </p:attrNameLst>
-                                      </p:cBhvr>
-                                      <p:to>
-                                        <p:strVal val="visible"/>
-                                      </p:to>
-                                    </p:set>
-                                    <p:animEffect transition="in" filter="fade">
-                                      <p:cBhvr>
-                                        <p:cTn id="7" dur="500"/>
-                                        <p:tgtEl>
-                                          <p:spTgt spid="243"/>
-                                        </p:tgtEl>
-                                      </p:cBhvr>
-                                    </p:animEffect>
-                                  </p:childTnLst>
-                                </p:cTn>
-                              </p:par>
-                            </p:childTnLst>
-                          </p:cTn>
-                        </p:par>
-                      </p:childTnLst>
-                    </p:cTn>
-                  </p:par>
-                  <p:par>
-                    <p:cTn id="8" fill="hold">
-                      <p:stCondLst>
-                        <p:cond delay="indefinite"/>
-                      </p:stCondLst>
-                      <p:childTnLst>
-                        <p:par>
-                          <p:cTn id="9" fill="hold">
-                            <p:stCondLst>
-                              <p:cond delay="0"/>
-                            </p:stCondLst>
-                            <p:childTnLst>
-                              <p:par>
-                                <p:cTn id="10" presetID="10" presetClass="entr" presetSubtype="0" fill="hold" grpId="0" nodeType="clickEffect">
-                                  <p:stCondLst>
-                                    <p:cond delay="0"/>
-                                  </p:stCondLst>
-                                  <p:childTnLst>
-                                    <p:set>
-                                      <p:cBhvr>
-                                        <p:cTn id="11" dur="1" fill="hold">
-                                          <p:stCondLst>
-                                            <p:cond delay="0"/>
-                                          </p:stCondLst>
-                                        </p:cTn>
-                                        <p:tgtEl>
-                                          <p:spTgt spid="244"/>
-                                        </p:tgtEl>
-                                        <p:attrNameLst>
-                                          <p:attrName>style.visibility</p:attrName>
-                                        </p:attrNameLst>
-                                      </p:cBhvr>
-                                      <p:to>
-                                        <p:strVal val="visible"/>
-                                      </p:to>
-                                    </p:set>
-                                    <p:animEffect transition="in" filter="fade">
-                                      <p:cBhvr>
-                                        <p:cTn id="12" dur="500"/>
-                                        <p:tgtEl>
-                                          <p:spTgt spid="244"/>
-                                        </p:tgtEl>
-                                      </p:cBhvr>
-                                    </p:animEffect>
-                                  </p:childTnLst>
-                                </p:cTn>
-                              </p:par>
-                            </p:childTnLst>
-                          </p:cTn>
-                        </p:par>
-                      </p:childTnLst>
-                    </p:cTn>
-                  </p:par>
-                </p:childTnLst>
-              </p:cTn>
-              <p:prevCondLst>
-                <p:cond evt="onPrev" delay="0">
-                  <p:tgtEl>
-                    <p:sldTgt/>
-                  </p:tgtEl>
-                </p:cond>
-              </p:prevCondLst>
-              <p:nextCondLst>
-                <p:cond evt="onNext" delay="0">
-                  <p:tgtEl>
-                    <p:sldTgt/>
-                  </p:tgtEl>
-                </p:cond>
-              </p:nextCondLst>
-            </p:seq>
-          </p:childTnLst>
-        </p:cTn>
-      </p:par>
-    </p:tnLst>
-  </p:timing>
 </p:sld>
 </file>
 

</xml_diff>